<commit_message>
Add Hira Baig as equal partner and co-signatory
- Service agreement names both partners, with CNIC lines, and has separate signature blocks for each
- Go-live & handover certificate adds Hira Baig's signature alongside Omer Bin Dawood's
- Welcome pack, deck team slide, contacts and closing slide list both partners

Co-Authored-By: Claude Opus 5.5 <noreply@anthropic.com>
Claude-Session: https://claude.ai/code/session_01BwHQN3UMKTYJBJKnCLWpNS
</commit_message>
<xml_diff>
--- a/GFX-T Onboarding Kit/PPT/00 - Kickoff Deck.pptx
+++ b/GFX-T Onboarding Kit/PPT/00 - Kickoff Deck.pptx
@@ -3869,7 +3869,7 @@
                 </a:solidFill>
                 <a:latin typeface="Inter"/>
               </a:rPr>
-              <a:t>Omer Bin Dawood</a:t>
+              <a:t>Omer Bin Dawood &amp; Hira Baig</a:t>
             </a:r>
           </a:p>
         </p:txBody>
@@ -5443,7 +5443,7 @@
         <p:spPr>
           <a:xfrm>
             <a:off x="731520" y="5760720"/>
-            <a:ext cx="5486400" cy="365760"/>
+            <a:ext cx="3657600" cy="365760"/>
           </a:xfrm>
           <a:prstGeom prst="rect">
             <a:avLst/>
@@ -5482,7 +5482,7 @@
         <p:spPr>
           <a:xfrm>
             <a:off x="731520" y="6126480"/>
-            <a:ext cx="7589520" cy="365760"/>
+            <a:ext cx="3657600" cy="365760"/>
           </a:xfrm>
           <a:prstGeom prst="rect">
             <a:avLst/>
@@ -5507,7 +5507,85 @@
                 </a:solidFill>
                 <a:latin typeface="Inter"/>
               </a:rPr>
-              <a:t>CEO &amp; Founder, OBD AI Solutions  ·  AI Engineer, DevNeuron (CA, USA)</a:t>
+              <a:t>CEO &amp; Founder, OBD AI Solutions</a:t>
+            </a:r>
+          </a:p>
+        </p:txBody>
+      </p:sp>
+      <p:sp>
+        <p:nvSpPr>
+          <p:cNvPr id="14" name="TextBox 13"/>
+          <p:cNvSpPr txBox="1"/>
+          <p:nvPr/>
+        </p:nvSpPr>
+        <p:spPr>
+          <a:xfrm>
+            <a:off x="4572000" y="5760720"/>
+            <a:ext cx="3657600" cy="365760"/>
+          </a:xfrm>
+          <a:prstGeom prst="rect">
+            <a:avLst/>
+          </a:prstGeom>
+          <a:noFill/>
+        </p:spPr>
+        <p:txBody>
+          <a:bodyPr wrap="square" lIns="0" rIns="0" tIns="0" bIns="0" anchor="t">
+            <a:spAutoFit/>
+          </a:bodyPr>
+          <a:lstStyle/>
+          <a:p>
+            <a:pPr algn="l">
+              <a:lnSpc>
+                <a:spcPct val="110000"/>
+              </a:lnSpc>
+            </a:pPr>
+            <a:r>
+              <a:rPr sz="1800" b="0" i="0">
+                <a:solidFill>
+                  <a:srgbClr val="FFFFFF"/>
+                </a:solidFill>
+                <a:latin typeface="Playfair Display"/>
+              </a:rPr>
+              <a:t>Hira Baig</a:t>
+            </a:r>
+          </a:p>
+        </p:txBody>
+      </p:sp>
+      <p:sp>
+        <p:nvSpPr>
+          <p:cNvPr id="15" name="TextBox 14"/>
+          <p:cNvSpPr txBox="1"/>
+          <p:nvPr/>
+        </p:nvSpPr>
+        <p:spPr>
+          <a:xfrm>
+            <a:off x="4572000" y="6126480"/>
+            <a:ext cx="3657600" cy="365760"/>
+          </a:xfrm>
+          <a:prstGeom prst="rect">
+            <a:avLst/>
+          </a:prstGeom>
+          <a:noFill/>
+        </p:spPr>
+        <p:txBody>
+          <a:bodyPr wrap="square" lIns="0" rIns="0" tIns="0" bIns="0" anchor="t">
+            <a:spAutoFit/>
+          </a:bodyPr>
+          <a:lstStyle/>
+          <a:p>
+            <a:pPr algn="l">
+              <a:lnSpc>
+                <a:spcPct val="110000"/>
+              </a:lnSpc>
+            </a:pPr>
+            <a:r>
+              <a:rPr sz="1050" b="0" i="0">
+                <a:solidFill>
+                  <a:srgbClr val="C9B4FF"/>
+                </a:solidFill>
+                <a:latin typeface="Inter"/>
+              </a:rPr>
+              <a:t>Co-Founder &amp; Partner, OBD AI Solutions</a:t>
             </a:r>
           </a:p>
         </p:txBody>
@@ -8965,7 +9043,7 @@
                 </a:solidFill>
                 <a:latin typeface="Playfair Display"/>
               </a:rPr>
-              <a:t>H</a:t>
+              <a:t>HB</a:t>
             </a:r>
           </a:p>
         </p:txBody>
@@ -9004,7 +9082,7 @@
                 </a:solidFill>
                 <a:latin typeface="Inter"/>
               </a:rPr>
-              <a:t>ACCOUNT MANAGER</a:t>
+              <a:t>CO-FOUNDER &amp; PARTNER</a:t>
             </a:r>
           </a:p>
         </p:txBody>
@@ -9043,7 +9121,7 @@
                 </a:solidFill>
                 <a:latin typeface="Playfair Display"/>
               </a:rPr>
-              <a:t>Hira</a:t>
+              <a:t>Hira Baig</a:t>
             </a:r>
           </a:p>
         </p:txBody>
@@ -9082,7 +9160,23 @@
                 </a:solidFill>
                 <a:latin typeface="Inter"/>
               </a:rPr>
-              <a:t>Client relations, OBD AI Solutions</a:t>
+              <a:t>Co-Founder &amp; Partner, OBD AI Solutions</a:t>
+            </a:r>
+          </a:p>
+          <a:p>
+            <a:pPr algn="l">
+              <a:lnSpc>
+                <a:spcPct val="120000"/>
+              </a:lnSpc>
+            </a:pPr>
+            <a:r>
+              <a:rPr sz="1050" b="0" i="0">
+                <a:solidFill>
+                  <a:srgbClr val="6B6878"/>
+                </a:solidFill>
+                <a:latin typeface="Inter"/>
+              </a:rPr>
+              <a:t>Client relations &amp; operations</a:t>
             </a:r>
           </a:p>
         </p:txBody>
@@ -16297,7 +16391,7 @@
                 </a:solidFill>
                 <a:latin typeface="Inter"/>
               </a:rPr>
-              <a:t>WhatsApp project group  ·  Hira (Account Manager)  ·  Omer Bin Dawood (escalations)</a:t>
+              <a:t>WhatsApp project group  ·  Hira Baig (Co-Founder &amp; Partner)  ·  Omer Bin Dawood (escalations)</a:t>
             </a:r>
           </a:p>
           <a:p>

</xml_diff>

<commit_message>
Retitle partners: Omer Bin Dawood as Founder, Hira Baig as Managing Director
Co-Authored-By: Claude Opus 5.5 <noreply@anthropic.com>
Claude-Session: https://claude.ai/code/session_01BwHQN3UMKTYJBJKnCLWpNS
</commit_message>
<xml_diff>
--- a/GFX-T Onboarding Kit/PPT/00 - Kickoff Deck.pptx
+++ b/GFX-T Onboarding Kit/PPT/00 - Kickoff Deck.pptx
@@ -5507,7 +5507,7 @@
                 </a:solidFill>
                 <a:latin typeface="Inter"/>
               </a:rPr>
-              <a:t>CEO &amp; Founder, OBD AI Solutions</a:t>
+              <a:t>Founder, OBD AI Solutions</a:t>
             </a:r>
           </a:p>
         </p:txBody>
@@ -5585,7 +5585,7 @@
                 </a:solidFill>
                 <a:latin typeface="Inter"/>
               </a:rPr>
-              <a:t>Co-Founder &amp; Partner, OBD AI Solutions</a:t>
+              <a:t>Managing Director, OBD AI Solutions</a:t>
             </a:r>
           </a:p>
         </p:txBody>
@@ -8843,7 +8843,7 @@
                 </a:solidFill>
                 <a:latin typeface="Inter"/>
               </a:rPr>
-              <a:t>CEO &amp; Founder, OBD AI Solutions</a:t>
+              <a:t>Founder, OBD AI Solutions</a:t>
             </a:r>
           </a:p>
           <a:p>
@@ -9082,7 +9082,7 @@
                 </a:solidFill>
                 <a:latin typeface="Inter"/>
               </a:rPr>
-              <a:t>CO-FOUNDER &amp; PARTNER</a:t>
+              <a:t>MANAGING DIRECTOR</a:t>
             </a:r>
           </a:p>
         </p:txBody>
@@ -9160,7 +9160,7 @@
                 </a:solidFill>
                 <a:latin typeface="Inter"/>
               </a:rPr>
-              <a:t>Co-Founder &amp; Partner, OBD AI Solutions</a:t>
+              <a:t>Managing Director, OBD AI Solutions</a:t>
             </a:r>
           </a:p>
           <a:p>
@@ -16391,7 +16391,7 @@
                 </a:solidFill>
                 <a:latin typeface="Inter"/>
               </a:rPr>
-              <a:t>WhatsApp project group  ·  Hira Baig (Co-Founder &amp; Partner)  ·  Omer Bin Dawood (escalations)</a:t>
+              <a:t>WhatsApp project group  ·  Hira Baig (Managing Director)  ·  Omer Bin Dawood (escalations)</a:t>
             </a:r>
           </a:p>
           <a:p>

</xml_diff>